<commit_message>
fix: adjust example deck text boxes to clear check overflow
</commit_message>
<xml_diff>
--- a/examples/Alien_Guide.pptx
+++ b/examples/Alien_Guide.pptx
@@ -1349,7 +1349,7 @@
         <p:spPr>
           <a:xfrm>
             <a:off x="1080000" y="3240000"/>
-            <a:ext cx="2160000" cy="540000"/>
+            <a:ext cx="2160000" cy="612000"/>
           </a:xfrm>
           <a:prstGeom prst="rect">
             <a:avLst/>
@@ -1488,7 +1488,7 @@
         <p:spPr>
           <a:xfrm>
             <a:off x="4860000" y="3240000"/>
-            <a:ext cx="2160000" cy="540000"/>
+            <a:ext cx="2160000" cy="612000"/>
           </a:xfrm>
           <a:prstGeom prst="rect">
             <a:avLst/>

</xml_diff>

<commit_message>
fix: clean pptx example baselines for check and validate (#47)
* test: capture pptx example baseline check and validate expectations

* fix: sanitize budget review baseline geometry XML

* fix: adjust example deck text boxes to clear check overflow
</commit_message>
<xml_diff>
--- a/examples/Alien_Guide.pptx
+++ b/examples/Alien_Guide.pptx
@@ -1349,7 +1349,7 @@
         <p:spPr>
           <a:xfrm>
             <a:off x="1080000" y="3240000"/>
-            <a:ext cx="2160000" cy="540000"/>
+            <a:ext cx="2160000" cy="612000"/>
           </a:xfrm>
           <a:prstGeom prst="rect">
             <a:avLst/>
@@ -1488,7 +1488,7 @@
         <p:spPr>
           <a:xfrm>
             <a:off x="4860000" y="3240000"/>
-            <a:ext cx="2160000" cy="540000"/>
+            <a:ext cx="2160000" cy="612000"/>
           </a:xfrm>
           <a:prstGeom prst="rect">
             <a:avLst/>

</xml_diff>